<commit_message>
Cut the fabricated ordering-bot story from the deck
Removed the passage from slide 25's speaker notes and deleted appendix source
S20 entirely, rather than leaving a false citation standing with a footnote
next to it.

Renumbered S21 through S24 down to S20 through S23 and updated every citation
on slides 7, 22 and 25 to match. Verified both directions afterwards: no
dangling tags, no orphaned entries, no numbering gaps, 23 sources defined and
all of them cited.

Re-rendered the title slide and contact sheet from the corrected deck, and
removed the correction notices from the README and the reference page since
there is no longer anything to correct.
</commit_message>
<xml_diff>
--- a/slides/AFS-DAFITC-2026-Accelerating-Mission-Readiness-v23.pptx
+++ b/slides/AFS-DAFITC-2026-Accelerating-Mission-Readiness-v23.pptx
@@ -2027,10 +2027,8 @@
           <a:lstStyle/>
           <a:p>
             <a:r>
-              <a:rPr lang="en-US" dirty="0"/>
-              <a:t>The DoD defined trustworthy in 2020 as five principles: responsible, equitable, traceable, reliable, and governable. [DoD AI Ethics Principles, February 2020; DoD Responsible AI Strategy and Implementation Pathway, June 2022.] The one that governs AI you turn loose in a mission is governable: the system detects unintended behavior and can disengage on command. If the only thing stopping an AI from doing the wrong thing is its own promise in a system prompt, you do not have a guardrail. You have a request. It can be jailbroken, and it drifts as the model changes. A real guardrail lives in the infrastructure. The action is blocked before the model ever decides, and every attempt is logged. A model is probabilistic; the same input does not produce the same output twice. Deterministic software gives the same result every time. That is why a promise inside the model cannot be a control and a rule outside it can. There is a live example from earlier this year. A customer-facing ordering bot was asked to solve a student's programming homework before taking their order. It did, then asked if they were ready to order. [S20] Nothing in that system's instructions told it to do homework. Nothing stopped it either, because the only thing in the way was a request. And this is why guardrails are not a second subject in this talk. In a high-risk environment you cannot claim a measured outcome on a mission workflow unless the enforcement is deterministic. They are the reason the outcome is trustworthy. And we demonstrate it, three beats. A request inside policy executes. A request outside policy, where the operator pushes and the model agrees to answer anyway. Then the call is denied at the policy layer before it executes. On how bypassable a self-enforced guardrail is: large reasoning models acting as autonomous jailbreak agents reached a 97.14 percent jailbreak success rate across model combinations. [Nature Communications, 2026.]</a:t>
-            </a:r>
-            <a:endParaRPr lang="en-US" dirty="0"/>
+              <a:t>The DoD defined trustworthy in 2020 as five principles: responsible, equitable, traceable, reliable, and governable. [DoD AI Ethics Principles, February 2020; DoD Responsible AI Strategy and Implementation Pathway, June 2022.] The one that governs AI you turn loose in a mission is governable: the system detects unintended behavior and can disengage on command. If the only thing stopping an AI from doing the wrong thing is its own promise in a system prompt, you do not have a guardrail. You have a request. It can be jailbroken, and it drifts as the model changes. A real guardrail lives in the infrastructure. The action is blocked before the model ever decides, and every attempt is logged. A model is probabilistic; the same input does not produce the same output twice. Deterministic software gives the same result every time. That is why a promise inside the model cannot be a control and a rule outside it can. And this is why guardrails are not a second subject in this talk. In a high-risk environment you cannot claim a measured outcome on a mission workflow unless the enforcement is deterministic. They are the reason the outcome is trustworthy. And we demonstrate it, three beats. A request inside policy executes. A request outside policy, where the operator pushes and the model agrees to answer anyway. Then the call is denied at the policy layer before it executes. On how bypassable a self-enforced guardrail is: large reasoning models acting as autonomous jailbreak agents reached a 97.14 percent jailbreak success rate across model combinations. [Nature Communications, 2026.]</a:t>
+            </a:r>
           </a:p>
         </p:txBody>
       </p:sp>
@@ -3579,6 +3577,10 @@
           </a:gradFill>
           <a:ln/>
         </p:spPr>
+        <p:txBody>
+          <a:bodyPr/>
+          <a:p/>
+        </p:txBody>
       </p:sp>
       <p:pic>
         <p:nvPicPr>
@@ -4163,6 +4165,10 @@
           </a:solidFill>
           <a:ln/>
         </p:spPr>
+        <p:txBody>
+          <a:bodyPr/>
+          <a:p/>
+        </p:txBody>
       </p:sp>
       <p:sp>
         <p:nvSpPr>
@@ -4315,6 +4321,10 @@
           </a:solidFill>
           <a:ln/>
         </p:spPr>
+        <p:txBody>
+          <a:bodyPr/>
+          <a:p/>
+        </p:txBody>
       </p:sp>
       <p:sp>
         <p:nvSpPr>
@@ -4467,6 +4477,10 @@
           </a:solidFill>
           <a:ln/>
         </p:spPr>
+        <p:txBody>
+          <a:bodyPr/>
+          <a:p/>
+        </p:txBody>
       </p:sp>
       <p:pic>
         <p:nvPicPr>
@@ -4887,6 +4901,10 @@
             <a:prstDash val="solid"/>
           </a:ln>
         </p:spPr>
+        <p:txBody>
+          <a:bodyPr/>
+          <a:p/>
+        </p:txBody>
       </p:sp>
       <p:sp>
         <p:nvSpPr>
@@ -4953,6 +4971,10 @@
           </a:solidFill>
           <a:ln/>
         </p:spPr>
+        <p:txBody>
+          <a:bodyPr/>
+          <a:p/>
+        </p:txBody>
       </p:sp>
       <p:sp>
         <p:nvSpPr>
@@ -5021,6 +5043,10 @@
             <a:prstDash val="solid"/>
           </a:ln>
         </p:spPr>
+        <p:txBody>
+          <a:bodyPr/>
+          <a:p/>
+        </p:txBody>
       </p:sp>
       <p:sp>
         <p:nvSpPr>
@@ -5517,6 +5543,10 @@
           </a:solidFill>
           <a:ln/>
         </p:spPr>
+        <p:txBody>
+          <a:bodyPr/>
+          <a:p/>
+        </p:txBody>
       </p:sp>
       <p:sp>
         <p:nvSpPr>
@@ -5642,6 +5672,10 @@
           </a:solidFill>
           <a:ln/>
         </p:spPr>
+        <p:txBody>
+          <a:bodyPr/>
+          <a:p/>
+        </p:txBody>
       </p:sp>
       <p:pic>
         <p:nvPicPr>
@@ -6062,6 +6096,10 @@
             <a:prstDash val="solid"/>
           </a:ln>
         </p:spPr>
+        <p:txBody>
+          <a:bodyPr/>
+          <a:p/>
+        </p:txBody>
       </p:sp>
       <p:pic>
         <p:nvPicPr>
@@ -6183,6 +6221,10 @@
           </a:solidFill>
           <a:ln/>
         </p:spPr>
+        <p:txBody>
+          <a:bodyPr/>
+          <a:p/>
+        </p:txBody>
       </p:sp>
       <p:sp>
         <p:nvSpPr>
@@ -6757,6 +6799,10 @@
             <a:prstDash val="solid"/>
           </a:ln>
         </p:spPr>
+        <p:txBody>
+          <a:bodyPr/>
+          <a:p/>
+        </p:txBody>
       </p:sp>
       <p:sp>
         <p:nvSpPr>
@@ -6827,6 +6873,10 @@
             <a:prstDash val="solid"/>
           </a:ln>
         </p:spPr>
+        <p:txBody>
+          <a:bodyPr/>
+          <a:p/>
+        </p:txBody>
       </p:sp>
       <p:sp>
         <p:nvSpPr>
@@ -6893,6 +6943,10 @@
           </a:solidFill>
           <a:ln/>
         </p:spPr>
+        <p:txBody>
+          <a:bodyPr/>
+          <a:p/>
+        </p:txBody>
       </p:sp>
       <p:sp>
         <p:nvSpPr>
@@ -7239,6 +7293,10 @@
           </a:solidFill>
           <a:ln/>
         </p:spPr>
+        <p:txBody>
+          <a:bodyPr/>
+          <a:p/>
+        </p:txBody>
       </p:sp>
       <p:sp>
         <p:nvSpPr>
@@ -7391,6 +7449,10 @@
           </a:solidFill>
           <a:ln/>
         </p:spPr>
+        <p:txBody>
+          <a:bodyPr/>
+          <a:p/>
+        </p:txBody>
       </p:sp>
       <p:sp>
         <p:nvSpPr>
@@ -7543,6 +7605,10 @@
           </a:solidFill>
           <a:ln/>
         </p:spPr>
+        <p:txBody>
+          <a:bodyPr/>
+          <a:p/>
+        </p:txBody>
       </p:sp>
       <p:sp>
         <p:nvSpPr>
@@ -7695,6 +7761,10 @@
           </a:solidFill>
           <a:ln/>
         </p:spPr>
+        <p:txBody>
+          <a:bodyPr/>
+          <a:p/>
+        </p:txBody>
       </p:sp>
       <p:pic>
         <p:nvPicPr>
@@ -8065,6 +8135,10 @@
           </a:solidFill>
           <a:ln/>
         </p:spPr>
+        <p:txBody>
+          <a:bodyPr/>
+          <a:p/>
+        </p:txBody>
       </p:sp>
       <p:sp>
         <p:nvSpPr>
@@ -8173,6 +8247,10 @@
           </a:solidFill>
           <a:ln/>
         </p:spPr>
+        <p:txBody>
+          <a:bodyPr/>
+          <a:p/>
+        </p:txBody>
       </p:sp>
       <p:sp>
         <p:nvSpPr>
@@ -8281,6 +8359,10 @@
           </a:solidFill>
           <a:ln/>
         </p:spPr>
+        <p:txBody>
+          <a:bodyPr/>
+          <a:p/>
+        </p:txBody>
       </p:sp>
       <p:sp>
         <p:nvSpPr>
@@ -8389,6 +8471,10 @@
           </a:solidFill>
           <a:ln/>
         </p:spPr>
+        <p:txBody>
+          <a:bodyPr/>
+          <a:p/>
+        </p:txBody>
       </p:sp>
       <p:sp>
         <p:nvSpPr>
@@ -8497,6 +8583,10 @@
           </a:solidFill>
           <a:ln/>
         </p:spPr>
+        <p:txBody>
+          <a:bodyPr/>
+          <a:p/>
+        </p:txBody>
       </p:sp>
       <p:sp>
         <p:nvSpPr>
@@ -8622,6 +8712,10 @@
           </a:solidFill>
           <a:ln/>
         </p:spPr>
+        <p:txBody>
+          <a:bodyPr/>
+          <a:p/>
+        </p:txBody>
       </p:sp>
       <p:pic>
         <p:nvPicPr>
@@ -9112,6 +9206,10 @@
             <a:prstDash val="solid"/>
           </a:ln>
         </p:spPr>
+        <p:txBody>
+          <a:bodyPr/>
+          <a:p/>
+        </p:txBody>
       </p:sp>
       <p:sp>
         <p:nvSpPr>
@@ -9176,6 +9274,10 @@
           </a:solidFill>
           <a:ln/>
         </p:spPr>
+        <p:txBody>
+          <a:bodyPr/>
+          <a:p/>
+        </p:txBody>
       </p:sp>
       <p:sp>
         <p:nvSpPr>
@@ -9284,6 +9386,10 @@
           </a:solidFill>
           <a:ln/>
         </p:spPr>
+        <p:txBody>
+          <a:bodyPr/>
+          <a:p/>
+        </p:txBody>
       </p:sp>
       <p:sp>
         <p:nvSpPr>
@@ -9392,6 +9498,10 @@
           </a:solidFill>
           <a:ln/>
         </p:spPr>
+        <p:txBody>
+          <a:bodyPr/>
+          <a:p/>
+        </p:txBody>
       </p:sp>
       <p:sp>
         <p:nvSpPr>
@@ -9500,6 +9610,10 @@
           </a:solidFill>
           <a:ln/>
         </p:spPr>
+        <p:txBody>
+          <a:bodyPr/>
+          <a:p/>
+        </p:txBody>
       </p:sp>
       <p:sp>
         <p:nvSpPr>
@@ -9608,6 +9722,10 @@
           </a:solidFill>
           <a:ln/>
         </p:spPr>
+        <p:txBody>
+          <a:bodyPr/>
+          <a:p/>
+        </p:txBody>
       </p:sp>
       <p:sp>
         <p:nvSpPr>
@@ -9674,6 +9792,10 @@
           </a:solidFill>
           <a:ln/>
         </p:spPr>
+        <p:txBody>
+          <a:bodyPr/>
+          <a:p/>
+        </p:txBody>
       </p:sp>
       <p:sp>
         <p:nvSpPr>
@@ -9786,6 +9908,10 @@
           </a:solidFill>
           <a:ln/>
         </p:spPr>
+        <p:txBody>
+          <a:bodyPr/>
+          <a:p/>
+        </p:txBody>
       </p:sp>
       <p:sp>
         <p:nvSpPr>
@@ -9898,6 +10024,10 @@
           </a:solidFill>
           <a:ln/>
         </p:spPr>
+        <p:txBody>
+          <a:bodyPr/>
+          <a:p/>
+        </p:txBody>
       </p:sp>
       <p:sp>
         <p:nvSpPr>
@@ -10010,6 +10140,10 @@
           </a:solidFill>
           <a:ln/>
         </p:spPr>
+        <p:txBody>
+          <a:bodyPr/>
+          <a:p/>
+        </p:txBody>
       </p:sp>
       <p:sp>
         <p:nvSpPr>
@@ -10507,6 +10641,10 @@
             <a:prstDash val="solid"/>
           </a:ln>
         </p:spPr>
+        <p:txBody>
+          <a:bodyPr/>
+          <a:p/>
+        </p:txBody>
       </p:sp>
       <p:pic>
         <p:nvPicPr>
@@ -10605,6 +10743,10 @@
           </a:solidFill>
           <a:ln/>
         </p:spPr>
+        <p:txBody>
+          <a:bodyPr/>
+          <a:p/>
+        </p:txBody>
       </p:sp>
       <p:sp>
         <p:nvSpPr>
@@ -10949,6 +11091,10 @@
           </a:gradFill>
           <a:ln/>
         </p:spPr>
+        <p:txBody>
+          <a:bodyPr/>
+          <a:p/>
+        </p:txBody>
       </p:sp>
       <p:pic>
         <p:nvPicPr>
@@ -11119,6 +11265,10 @@
           </a:solidFill>
           <a:ln/>
         </p:spPr>
+        <p:txBody>
+          <a:bodyPr/>
+          <a:p/>
+        </p:txBody>
       </p:sp>
       <p:sp>
         <p:nvSpPr>
@@ -11429,6 +11579,10 @@
             <a:prstDash val="solid"/>
           </a:ln>
         </p:spPr>
+        <p:txBody>
+          <a:bodyPr/>
+          <a:p/>
+        </p:txBody>
       </p:sp>
       <p:sp>
         <p:nvSpPr>
@@ -11449,6 +11603,10 @@
           </a:solidFill>
           <a:ln/>
         </p:spPr>
+        <p:txBody>
+          <a:bodyPr/>
+          <a:p/>
+        </p:txBody>
       </p:sp>
       <p:pic>
         <p:nvPicPr>
@@ -12431,6 +12589,10 @@
           </a:solidFill>
           <a:ln/>
         </p:spPr>
+        <p:txBody>
+          <a:bodyPr/>
+          <a:p/>
+        </p:txBody>
       </p:sp>
       <p:sp>
         <p:nvSpPr>
@@ -12739,6 +12901,10 @@
           </a:solidFill>
           <a:ln/>
         </p:spPr>
+        <p:txBody>
+          <a:bodyPr/>
+          <a:p/>
+        </p:txBody>
       </p:sp>
       <p:sp>
         <p:nvSpPr>
@@ -12849,6 +13015,10 @@
             <a:prstDash val="solid"/>
           </a:ln>
         </p:spPr>
+        <p:txBody>
+          <a:bodyPr/>
+          <a:p/>
+        </p:txBody>
       </p:sp>
       <p:sp>
         <p:nvSpPr>
@@ -12869,6 +13039,10 @@
           </a:solidFill>
           <a:ln/>
         </p:spPr>
+        <p:txBody>
+          <a:bodyPr/>
+          <a:p/>
+        </p:txBody>
       </p:sp>
       <p:pic>
         <p:nvPicPr>
@@ -13142,6 +13316,10 @@
           </a:gradFill>
           <a:ln/>
         </p:spPr>
+        <p:txBody>
+          <a:bodyPr/>
+          <a:p/>
+        </p:txBody>
       </p:sp>
       <p:sp>
         <p:nvSpPr>
@@ -14394,6 +14572,10 @@
           </a:solidFill>
           <a:ln/>
         </p:spPr>
+        <p:txBody>
+          <a:bodyPr/>
+          <a:p/>
+        </p:txBody>
       </p:sp>
       <p:sp>
         <p:nvSpPr>
@@ -14494,7 +14676,7 @@
                 <a:ea typeface="Courier New" pitchFamily="34" charset="-122"/>
                 <a:cs typeface="Courier New" pitchFamily="34" charset="-120"/>
               </a:rPr>
-              <a:t>S21</a:t>
+              <a:t>S20</a:t>
             </a:r>
             <a:endParaRPr lang="en-US" sz="1800" dirty="0"/>
           </a:p>
@@ -14519,6 +14701,10 @@
           </a:solidFill>
           <a:ln/>
         </p:spPr>
+        <p:txBody>
+          <a:bodyPr/>
+          <a:p/>
+        </p:txBody>
       </p:sp>
       <p:sp>
         <p:nvSpPr>
@@ -14710,7 +14896,7 @@
                 <a:ea typeface="Courier New" pitchFamily="34" charset="-122"/>
                 <a:cs typeface="Courier New" pitchFamily="34" charset="-120"/>
               </a:rPr>
-              <a:t>S23</a:t>
+              <a:t>S22</a:t>
             </a:r>
             <a:endParaRPr lang="en-US" sz="2025" dirty="0"/>
           </a:p>
@@ -15011,6 +15197,10 @@
           </a:solidFill>
           <a:ln/>
         </p:spPr>
+        <p:txBody>
+          <a:bodyPr/>
+          <a:p/>
+        </p:txBody>
       </p:sp>
       <p:sp>
         <p:nvSpPr>
@@ -15163,6 +15353,10 @@
           </a:solidFill>
           <a:ln/>
         </p:spPr>
+        <p:txBody>
+          <a:bodyPr/>
+          <a:p/>
+        </p:txBody>
       </p:sp>
       <p:sp>
         <p:nvSpPr>
@@ -15315,6 +15509,10 @@
           </a:solidFill>
           <a:ln/>
         </p:spPr>
+        <p:txBody>
+          <a:bodyPr/>
+          <a:p/>
+        </p:txBody>
       </p:sp>
       <p:sp>
         <p:nvSpPr>
@@ -15467,6 +15665,10 @@
           </a:solidFill>
           <a:ln/>
         </p:spPr>
+        <p:txBody>
+          <a:bodyPr/>
+          <a:p/>
+        </p:txBody>
       </p:sp>
       <p:sp>
         <p:nvSpPr>
@@ -15619,6 +15821,10 @@
           </a:solidFill>
           <a:ln/>
         </p:spPr>
+        <p:txBody>
+          <a:bodyPr/>
+          <a:p/>
+        </p:txBody>
       </p:sp>
       <p:sp>
         <p:nvSpPr>
@@ -15771,6 +15977,10 @@
           </a:solidFill>
           <a:ln/>
         </p:spPr>
+        <p:txBody>
+          <a:bodyPr/>
+          <a:p/>
+        </p:txBody>
       </p:sp>
       <p:sp>
         <p:nvSpPr>
@@ -15925,6 +16135,10 @@
             <a:prstDash val="solid"/>
           </a:ln>
         </p:spPr>
+        <p:txBody>
+          <a:bodyPr/>
+          <a:p/>
+        </p:txBody>
       </p:sp>
       <p:sp>
         <p:nvSpPr>
@@ -16077,6 +16291,10 @@
           </a:solidFill>
           <a:ln/>
         </p:spPr>
+        <p:txBody>
+          <a:bodyPr/>
+          <a:p/>
+        </p:txBody>
       </p:sp>
       <p:sp>
         <p:nvSpPr>
@@ -16185,6 +16403,10 @@
           </a:solidFill>
           <a:ln/>
         </p:spPr>
+        <p:txBody>
+          <a:bodyPr/>
+          <a:p/>
+        </p:txBody>
       </p:sp>
       <p:pic>
         <p:nvPicPr>
@@ -16423,6 +16645,10 @@
           </a:solidFill>
           <a:ln/>
         </p:spPr>
+        <p:txBody>
+          <a:bodyPr/>
+          <a:p/>
+        </p:txBody>
       </p:sp>
       <p:sp>
         <p:nvSpPr>
@@ -16533,6 +16759,10 @@
             <a:prstDash val="solid"/>
           </a:ln>
         </p:spPr>
+        <p:txBody>
+          <a:bodyPr/>
+          <a:p/>
+        </p:txBody>
       </p:sp>
       <p:sp>
         <p:nvSpPr>
@@ -16599,6 +16829,10 @@
             <a:prstDash val="solid"/>
           </a:ln>
         </p:spPr>
+        <p:txBody>
+          <a:bodyPr/>
+          <a:p/>
+        </p:txBody>
       </p:sp>
       <p:sp>
         <p:nvSpPr>
@@ -16665,6 +16899,10 @@
             <a:prstDash val="solid"/>
           </a:ln>
         </p:spPr>
+        <p:txBody>
+          <a:bodyPr/>
+          <a:p/>
+        </p:txBody>
       </p:sp>
       <p:sp>
         <p:nvSpPr>
@@ -16731,6 +16969,10 @@
             <a:prstDash val="solid"/>
           </a:ln>
         </p:spPr>
+        <p:txBody>
+          <a:bodyPr/>
+          <a:p/>
+        </p:txBody>
       </p:sp>
       <p:sp>
         <p:nvSpPr>
@@ -16797,6 +17039,10 @@
             <a:prstDash val="solid"/>
           </a:ln>
         </p:spPr>
+        <p:txBody>
+          <a:bodyPr/>
+          <a:p/>
+        </p:txBody>
       </p:sp>
       <p:sp>
         <p:nvSpPr>
@@ -16861,6 +17107,10 @@
           </a:solidFill>
           <a:ln/>
         </p:spPr>
+        <p:txBody>
+          <a:bodyPr/>
+          <a:p/>
+        </p:txBody>
       </p:sp>
       <p:sp>
         <p:nvSpPr>
@@ -17013,6 +17263,10 @@
           </a:solidFill>
           <a:ln/>
         </p:spPr>
+        <p:txBody>
+          <a:bodyPr/>
+          <a:p/>
+        </p:txBody>
       </p:sp>
       <p:pic>
         <p:nvPicPr>
@@ -17495,6 +17749,10 @@
           </a:solidFill>
           <a:ln/>
         </p:spPr>
+        <p:txBody>
+          <a:bodyPr/>
+          <a:p/>
+        </p:txBody>
       </p:sp>
       <p:sp>
         <p:nvSpPr>
@@ -17867,6 +18125,10 @@
           </a:solidFill>
           <a:ln/>
         </p:spPr>
+        <p:txBody>
+          <a:bodyPr/>
+          <a:p/>
+        </p:txBody>
       </p:sp>
       <p:sp>
         <p:nvSpPr>
@@ -17931,6 +18193,10 @@
           </a:solidFill>
           <a:ln/>
         </p:spPr>
+        <p:txBody>
+          <a:bodyPr/>
+          <a:p/>
+        </p:txBody>
       </p:sp>
       <p:sp>
         <p:nvSpPr>
@@ -17995,6 +18261,10 @@
           </a:solidFill>
           <a:ln/>
         </p:spPr>
+        <p:txBody>
+          <a:bodyPr/>
+          <a:p/>
+        </p:txBody>
       </p:sp>
       <p:sp>
         <p:nvSpPr>
@@ -18059,6 +18329,10 @@
           </a:solidFill>
           <a:ln/>
         </p:spPr>
+        <p:txBody>
+          <a:bodyPr/>
+          <a:p/>
+        </p:txBody>
       </p:sp>
       <p:sp>
         <p:nvSpPr>
@@ -18115,7 +18389,7 @@
                 <a:ea typeface="Courier New" pitchFamily="34" charset="-122"/>
                 <a:cs typeface="Courier New" pitchFamily="34" charset="-120"/>
               </a:rPr>
-              <a:t>S24</a:t>
+              <a:t>S23</a:t>
             </a:r>
             <a:endParaRPr lang="en-US" sz="1875" dirty="0"/>
           </a:p>
@@ -18140,6 +18414,10 @@
           </a:solidFill>
           <a:ln/>
         </p:spPr>
+        <p:txBody>
+          <a:bodyPr/>
+          <a:p/>
+        </p:txBody>
       </p:sp>
       <p:sp>
         <p:nvSpPr>
@@ -18204,6 +18482,10 @@
           </a:solidFill>
           <a:ln/>
         </p:spPr>
+        <p:txBody>
+          <a:bodyPr/>
+          <a:p/>
+        </p:txBody>
       </p:sp>
       <p:sp>
         <p:nvSpPr>
@@ -18270,6 +18552,10 @@
           </a:solidFill>
           <a:ln/>
         </p:spPr>
+        <p:txBody>
+          <a:bodyPr/>
+          <a:p/>
+        </p:txBody>
       </p:sp>
       <p:sp>
         <p:nvSpPr>
@@ -18336,6 +18622,10 @@
           </a:solidFill>
           <a:ln/>
         </p:spPr>
+        <p:txBody>
+          <a:bodyPr/>
+          <a:p/>
+        </p:txBody>
       </p:sp>
       <p:sp>
         <p:nvSpPr>
@@ -18402,6 +18692,10 @@
           </a:solidFill>
           <a:ln/>
         </p:spPr>
+        <p:txBody>
+          <a:bodyPr/>
+          <a:p/>
+        </p:txBody>
       </p:sp>
       <p:sp>
         <p:nvSpPr>
@@ -18468,6 +18762,10 @@
           </a:solidFill>
           <a:ln/>
         </p:spPr>
+        <p:txBody>
+          <a:bodyPr/>
+          <a:p/>
+        </p:txBody>
       </p:sp>
       <p:sp>
         <p:nvSpPr>
@@ -18554,6 +18852,10 @@
           </a:gradFill>
           <a:ln/>
         </p:spPr>
+        <p:txBody>
+          <a:bodyPr/>
+          <a:p/>
+        </p:txBody>
       </p:sp>
       <p:pic>
         <p:nvPicPr>
@@ -18724,6 +19026,10 @@
           </a:solidFill>
           <a:ln/>
         </p:spPr>
+        <p:txBody>
+          <a:bodyPr/>
+          <a:p/>
+        </p:txBody>
       </p:sp>
       <p:pic>
         <p:nvPicPr>
@@ -18812,6 +19118,10 @@
           </a:solidFill>
           <a:ln/>
         </p:spPr>
+        <p:txBody>
+          <a:bodyPr/>
+          <a:p/>
+        </p:txBody>
       </p:sp>
       <p:sp>
         <p:nvSpPr>
@@ -18964,6 +19274,10 @@
           </a:solidFill>
           <a:ln/>
         </p:spPr>
+        <p:txBody>
+          <a:bodyPr/>
+          <a:p/>
+        </p:txBody>
       </p:sp>
       <p:sp>
         <p:nvSpPr>
@@ -19160,6 +19474,10 @@
           </a:solidFill>
           <a:ln/>
         </p:spPr>
+        <p:txBody>
+          <a:bodyPr/>
+          <a:p/>
+        </p:txBody>
       </p:sp>
       <p:sp>
         <p:nvSpPr>
@@ -19356,6 +19674,10 @@
           </a:solidFill>
           <a:ln/>
         </p:spPr>
+        <p:txBody>
+          <a:bodyPr/>
+          <a:p/>
+        </p:txBody>
       </p:sp>
       <p:sp>
         <p:nvSpPr>
@@ -19552,6 +19874,10 @@
           </a:solidFill>
           <a:ln/>
         </p:spPr>
+        <p:txBody>
+          <a:bodyPr/>
+          <a:p/>
+        </p:txBody>
       </p:sp>
       <p:sp>
         <p:nvSpPr>
@@ -19786,6 +20112,10 @@
           </a:solidFill>
           <a:ln/>
         </p:spPr>
+        <p:txBody>
+          <a:bodyPr/>
+          <a:p/>
+        </p:txBody>
       </p:sp>
       <p:pic>
         <p:nvPicPr>
@@ -19880,6 +20210,10 @@
           </a:solidFill>
           <a:ln/>
         </p:spPr>
+        <p:txBody>
+          <a:bodyPr/>
+          <a:p/>
+        </p:txBody>
       </p:sp>
       <p:sp>
         <p:nvSpPr>
@@ -20481,6 +20815,10 @@
           </a:solidFill>
           <a:ln/>
         </p:spPr>
+        <p:txBody>
+          <a:bodyPr/>
+          <a:p/>
+        </p:txBody>
       </p:sp>
       <p:sp>
         <p:nvSpPr>
@@ -20633,6 +20971,10 @@
           </a:solidFill>
           <a:ln/>
         </p:spPr>
+        <p:txBody>
+          <a:bodyPr/>
+          <a:p/>
+        </p:txBody>
       </p:sp>
       <p:sp>
         <p:nvSpPr>
@@ -20785,6 +21127,10 @@
           </a:solidFill>
           <a:ln/>
         </p:spPr>
+        <p:txBody>
+          <a:bodyPr/>
+          <a:p/>
+        </p:txBody>
       </p:sp>
       <p:sp>
         <p:nvSpPr>
@@ -23060,6 +23406,10 @@
             <a:prstDash val="solid"/>
           </a:ln>
         </p:spPr>
+        <p:txBody>
+          <a:bodyPr/>
+          <a:p/>
+        </p:txBody>
       </p:sp>
       <p:sp>
         <p:nvSpPr>
@@ -23102,6 +23452,10 @@
           </a:gradFill>
           <a:ln/>
         </p:spPr>
+        <p:txBody>
+          <a:bodyPr/>
+          <a:p/>
+        </p:txBody>
       </p:sp>
       <p:sp>
         <p:nvSpPr>
@@ -23229,6 +23583,10 @@
             <a:prstDash val="solid"/>
           </a:ln>
         </p:spPr>
+        <p:txBody>
+          <a:bodyPr/>
+          <a:p/>
+        </p:txBody>
       </p:sp>
       <p:sp>
         <p:nvSpPr>
@@ -23271,6 +23629,10 @@
           </a:gradFill>
           <a:ln/>
         </p:spPr>
+        <p:txBody>
+          <a:bodyPr/>
+          <a:p/>
+        </p:txBody>
       </p:sp>
       <p:sp>
         <p:nvSpPr>
@@ -23398,6 +23760,10 @@
             <a:prstDash val="solid"/>
           </a:ln>
         </p:spPr>
+        <p:txBody>
+          <a:bodyPr/>
+          <a:p/>
+        </p:txBody>
       </p:sp>
       <p:sp>
         <p:nvSpPr>
@@ -23440,6 +23806,10 @@
           </a:gradFill>
           <a:ln/>
         </p:spPr>
+        <p:txBody>
+          <a:bodyPr/>
+          <a:p/>
+        </p:txBody>
       </p:sp>
       <p:sp>
         <p:nvSpPr>
@@ -23567,6 +23937,10 @@
             <a:prstDash val="solid"/>
           </a:ln>
         </p:spPr>
+        <p:txBody>
+          <a:bodyPr/>
+          <a:p/>
+        </p:txBody>
       </p:sp>
       <p:sp>
         <p:nvSpPr>
@@ -23609,6 +23983,10 @@
           </a:gradFill>
           <a:ln/>
         </p:spPr>
+        <p:txBody>
+          <a:bodyPr/>
+          <a:p/>
+        </p:txBody>
       </p:sp>
       <p:sp>
         <p:nvSpPr>
@@ -23734,6 +24112,10 @@
           </a:solidFill>
           <a:ln/>
         </p:spPr>
+        <p:txBody>
+          <a:bodyPr/>
+          <a:p/>
+        </p:txBody>
       </p:sp>
       <p:pic>
         <p:nvPicPr>
@@ -25299,7 +25681,7 @@
                 <a:ea typeface="Arial" pitchFamily="34" charset="-122"/>
                 <a:cs typeface="Arial" pitchFamily="34" charset="-120"/>
               </a:rPr>
-              <a:t>Sources, S17 to S24</a:t>
+              <a:t>Sources, S17 to S23</a:t>
             </a:r>
             <a:endParaRPr lang="en-US" sz="4200" dirty="0"/>
           </a:p>
@@ -25798,7 +26180,7 @@
                 <a:ea typeface="Arial" pitchFamily="34" charset="-122"/>
                 <a:cs typeface="Arial" pitchFamily="34" charset="-120"/>
               </a:rPr>
-              <a:t>Customer-facing ordering bot completes programming homework. </a:t>
+              <a:t>PANDA, Predictive Analytics and Decision Assistant. Rapid Sustainment Office. Selected as an Air Force system of record. DefenseScoop, May 10, 2023</a:t>
             </a:r>
             <a:pPr algn="l" indent="0" marL="0">
               <a:lnSpc>
@@ -25806,17 +26188,6 @@
               </a:lnSpc>
               <a:buNone/>
             </a:pPr>
-            <a:r>
-              <a:rPr lang="en-US" sz="1800" dirty="0">
-                <a:solidFill>
-                  <a:srgbClr val="96968C"/>
-                </a:solidFill>
-                <a:latin typeface="Arial" pitchFamily="34" charset="0"/>
-                <a:ea typeface="Arial" pitchFamily="34" charset="-122"/>
-                <a:cs typeface="Arial" pitchFamily="34" charset="-120"/>
-              </a:rPr>
-              <a:t>Media reporting, 2026</a:t>
-            </a:r>
             <a:endParaRPr lang="en-US" sz="1800" dirty="0"/>
           </a:p>
         </p:txBody>
@@ -25927,7 +26298,7 @@
                 <a:ea typeface="Arial" pitchFamily="34" charset="-122"/>
                 <a:cs typeface="Arial" pitchFamily="34" charset="-120"/>
               </a:rPr>
-              <a:t>PANDA, Predictive Analytics and Decision Assistant. Rapid Sustainment Office. </a:t>
+              <a:t>Air Force Proficiency Code Key. CFETP 2R1X1 and CFETP 3S2X1. Confirmed 26 August 2026</a:t>
             </a:r>
             <a:pPr algn="l" indent="0" marL="0">
               <a:lnSpc>
@@ -25935,17 +26306,6 @@
               </a:lnSpc>
               <a:buNone/>
             </a:pPr>
-            <a:r>
-              <a:rPr lang="en-US" sz="1800" dirty="0">
-                <a:solidFill>
-                  <a:srgbClr val="96968C"/>
-                </a:solidFill>
-                <a:latin typeface="Arial" pitchFamily="34" charset="0"/>
-                <a:ea typeface="Arial" pitchFamily="34" charset="-122"/>
-                <a:cs typeface="Arial" pitchFamily="34" charset="-120"/>
-              </a:rPr>
-              <a:t>Selected as an Air Force system of record. DefenseScoop, May 10, 2023</a:t>
-            </a:r>
             <a:endParaRPr lang="en-US" sz="1800" dirty="0"/>
           </a:p>
         </p:txBody>
@@ -26056,7 +26416,7 @@
                 <a:ea typeface="Arial" pitchFamily="34" charset="-122"/>
                 <a:cs typeface="Arial" pitchFamily="34" charset="-120"/>
               </a:rPr>
-              <a:t>Air Force Proficiency Code Key. </a:t>
+              <a:t>The 10-20-70 rule of AI transformation. Boston Consulting Group. Roughly 10 percent algorithms, 20 percent technology and data, 70 percent people and process</a:t>
             </a:r>
             <a:pPr algn="l" indent="0" marL="0">
               <a:lnSpc>
@@ -26064,17 +26424,6 @@
               </a:lnSpc>
               <a:buNone/>
             </a:pPr>
-            <a:r>
-              <a:rPr lang="en-US" sz="1800" dirty="0">
-                <a:solidFill>
-                  <a:srgbClr val="96968C"/>
-                </a:solidFill>
-                <a:latin typeface="Arial" pitchFamily="34" charset="0"/>
-                <a:ea typeface="Arial" pitchFamily="34" charset="-122"/>
-                <a:cs typeface="Arial" pitchFamily="34" charset="-120"/>
-              </a:rPr>
-              <a:t>CFETP 2R1X1 and CFETP 3S2X1. Confirmed 26 August 2026</a:t>
-            </a:r>
             <a:endParaRPr lang="en-US" sz="1800" dirty="0"/>
           </a:p>
         </p:txBody>
@@ -26185,7 +26534,7 @@
                 <a:ea typeface="Arial" pitchFamily="34" charset="-122"/>
                 <a:cs typeface="Arial" pitchFamily="34" charset="-120"/>
               </a:rPr>
-              <a:t>The 10-20-70 rule of AI transformation. </a:t>
+              <a:t>Large reasoning models as autonomous jailbreak agents. Nature Communications, 2026. 97.14 percent jailbreak success rate across model combinations</a:t>
             </a:r>
             <a:pPr algn="l" indent="0" marL="0">
               <a:lnSpc>
@@ -26193,146 +26542,6 @@
               </a:lnSpc>
               <a:buNone/>
             </a:pPr>
-            <a:r>
-              <a:rPr lang="en-US" sz="1800" dirty="0">
-                <a:solidFill>
-                  <a:srgbClr val="96968C"/>
-                </a:solidFill>
-                <a:latin typeface="Arial" pitchFamily="34" charset="0"/>
-                <a:ea typeface="Arial" pitchFamily="34" charset="-122"/>
-                <a:cs typeface="Arial" pitchFamily="34" charset="-120"/>
-              </a:rPr>
-              <a:t>Boston Consulting Group. Roughly 10 percent algorithms, 20 percent technology and data, 70 percent people and process</a:t>
-            </a:r>
-            <a:endParaRPr lang="en-US" sz="1800" dirty="0"/>
-          </a:p>
-        </p:txBody>
-      </p:sp>
-      <p:sp>
-        <p:nvSpPr>
-          <p:cNvPr id="26" name="Shape 23"/>
-          <p:cNvSpPr/>
-          <p:nvPr/>
-        </p:nvSpPr>
-        <p:spPr>
-          <a:xfrm>
-            <a:off x="9525000" y="6869708"/>
-            <a:ext cx="614759" cy="317500"/>
-          </a:xfrm>
-          <a:prstGeom prst="roundRect">
-            <a:avLst>
-              <a:gd name="adj" fmla="val 6000"/>
-            </a:avLst>
-          </a:prstGeom>
-          <a:ln w="6350">
-            <a:solidFill>
-              <a:srgbClr val="DCAFFF"/>
-            </a:solidFill>
-            <a:prstDash val="solid"/>
-          </a:ln>
-        </p:spPr>
-      </p:sp>
-      <p:sp>
-        <p:nvSpPr>
-          <p:cNvPr id="27" name="Text 24"/>
-          <p:cNvSpPr/>
-          <p:nvPr/>
-        </p:nvSpPr>
-        <p:spPr>
-          <a:xfrm>
-            <a:off x="9626600" y="6914158"/>
-            <a:ext cx="473035" cy="266700"/>
-          </a:xfrm>
-          <a:prstGeom prst="rect">
-            <a:avLst/>
-          </a:prstGeom>
-          <a:noFill/>
-          <a:ln/>
-        </p:spPr>
-        <p:txBody>
-          <a:bodyPr wrap="none" lIns="25400" tIns="25400" rIns="25400" bIns="25400" rtlCol="0" anchor="t">
-            <a:normAutofit/>
-          </a:bodyPr>
-          <a:lstStyle/>
-          <a:p>
-            <a:pPr algn="l" indent="0" marL="0">
-              <a:lnSpc>
-                <a:spcPct val="87805"/>
-              </a:lnSpc>
-              <a:buNone/>
-            </a:pPr>
-            <a:r>
-              <a:rPr lang="en-US" sz="1800" dirty="0">
-                <a:solidFill>
-                  <a:srgbClr val="7500C0"/>
-                </a:solidFill>
-                <a:latin typeface="Courier New" pitchFamily="34" charset="0"/>
-                <a:ea typeface="Courier New" pitchFamily="34" charset="-122"/>
-                <a:cs typeface="Courier New" pitchFamily="34" charset="-120"/>
-              </a:rPr>
-              <a:t>S24</a:t>
-            </a:r>
-            <a:endParaRPr lang="en-US" sz="1800" dirty="0"/>
-          </a:p>
-        </p:txBody>
-      </p:sp>
-      <p:sp>
-        <p:nvSpPr>
-          <p:cNvPr id="28" name="Text 25"/>
-          <p:cNvSpPr/>
-          <p:nvPr/>
-        </p:nvSpPr>
-        <p:spPr>
-          <a:xfrm>
-            <a:off x="10292160" y="6850658"/>
-            <a:ext cx="7058426" cy="970161"/>
-          </a:xfrm>
-          <a:prstGeom prst="rect">
-            <a:avLst/>
-          </a:prstGeom>
-          <a:noFill/>
-          <a:ln/>
-        </p:spPr>
-        <p:txBody>
-          <a:bodyPr wrap="square" lIns="25400" tIns="25400" rIns="25400" bIns="25400" rtlCol="0" anchor="t">
-            <a:normAutofit/>
-          </a:bodyPr>
-          <a:lstStyle/>
-          <a:p>
-            <a:pPr algn="l" indent="0" marL="0">
-              <a:lnSpc>
-                <a:spcPct val="115714"/>
-              </a:lnSpc>
-              <a:buNone/>
-            </a:pPr>
-            <a:r>
-              <a:rPr lang="en-US" sz="1800" b="1" dirty="0">
-                <a:solidFill>
-                  <a:srgbClr val="000000"/>
-                </a:solidFill>
-                <a:latin typeface="Arial" pitchFamily="34" charset="0"/>
-                <a:ea typeface="Arial" pitchFamily="34" charset="-122"/>
-                <a:cs typeface="Arial" pitchFamily="34" charset="-120"/>
-              </a:rPr>
-              <a:t>Large reasoning models as autonomous jailbreak agents. </a:t>
-            </a:r>
-            <a:pPr algn="l" indent="0" marL="0">
-              <a:lnSpc>
-                <a:spcPct val="115714"/>
-              </a:lnSpc>
-              <a:buNone/>
-            </a:pPr>
-            <a:r>
-              <a:rPr lang="en-US" sz="1800" dirty="0">
-                <a:solidFill>
-                  <a:srgbClr val="96968C"/>
-                </a:solidFill>
-                <a:latin typeface="Arial" pitchFamily="34" charset="0"/>
-                <a:ea typeface="Arial" pitchFamily="34" charset="-122"/>
-                <a:cs typeface="Arial" pitchFamily="34" charset="-120"/>
-              </a:rPr>
-              <a:t>Nature Communications, 2026. 97.14 percent jailbreak success rate across model combinations</a:t>
-            </a:r>
             <a:endParaRPr lang="en-US" sz="1800" dirty="0"/>
           </a:p>
         </p:txBody>
@@ -26546,6 +26755,10 @@
             <a:prstDash val="solid"/>
           </a:ln>
         </p:spPr>
+        <p:txBody>
+          <a:bodyPr/>
+          <a:p/>
+        </p:txBody>
       </p:sp>
       <p:sp>
         <p:nvSpPr>
@@ -26588,6 +26801,10 @@
           </a:gradFill>
           <a:ln/>
         </p:spPr>
+        <p:txBody>
+          <a:bodyPr/>
+          <a:p/>
+        </p:txBody>
       </p:sp>
       <p:sp>
         <p:nvSpPr>
@@ -26759,6 +26976,10 @@
             <a:prstDash val="solid"/>
           </a:ln>
         </p:spPr>
+        <p:txBody>
+          <a:bodyPr/>
+          <a:p/>
+        </p:txBody>
       </p:sp>
       <p:sp>
         <p:nvSpPr>
@@ -26801,6 +27022,10 @@
           </a:gradFill>
           <a:ln/>
         </p:spPr>
+        <p:txBody>
+          <a:bodyPr/>
+          <a:p/>
+        </p:txBody>
       </p:sp>
       <p:sp>
         <p:nvSpPr>
@@ -26972,6 +27197,10 @@
             <a:prstDash val="solid"/>
           </a:ln>
         </p:spPr>
+        <p:txBody>
+          <a:bodyPr/>
+          <a:p/>
+        </p:txBody>
       </p:sp>
       <p:sp>
         <p:nvSpPr>
@@ -27014,6 +27243,10 @@
           </a:gradFill>
           <a:ln/>
         </p:spPr>
+        <p:txBody>
+          <a:bodyPr/>
+          <a:p/>
+        </p:txBody>
       </p:sp>
       <p:sp>
         <p:nvSpPr>
@@ -27212,6 +27445,10 @@
             <a:prstDash val="solid"/>
           </a:ln>
         </p:spPr>
+        <p:txBody>
+          <a:bodyPr/>
+          <a:p/>
+        </p:txBody>
       </p:sp>
       <p:sp>
         <p:nvSpPr>
@@ -27254,6 +27491,10 @@
           </a:gradFill>
           <a:ln/>
         </p:spPr>
+        <p:txBody>
+          <a:bodyPr/>
+          <a:p/>
+        </p:txBody>
       </p:sp>
       <p:sp>
         <p:nvSpPr>
@@ -27585,6 +27826,10 @@
           </a:gradFill>
           <a:ln/>
         </p:spPr>
+        <p:txBody>
+          <a:bodyPr/>
+          <a:p/>
+        </p:txBody>
       </p:sp>
       <p:sp>
         <p:nvSpPr>
@@ -28267,6 +28512,10 @@
           </a:solidFill>
           <a:ln/>
         </p:spPr>
+        <p:txBody>
+          <a:bodyPr/>
+          <a:p/>
+        </p:txBody>
       </p:sp>
       <p:sp>
         <p:nvSpPr>
@@ -28392,6 +28641,10 @@
           </a:solidFill>
           <a:ln/>
         </p:spPr>
+        <p:txBody>
+          <a:bodyPr/>
+          <a:p/>
+        </p:txBody>
       </p:sp>
       <p:sp>
         <p:nvSpPr>
@@ -28500,6 +28753,10 @@
           </a:solidFill>
           <a:ln/>
         </p:spPr>
+        <p:txBody>
+          <a:bodyPr/>
+          <a:p/>
+        </p:txBody>
       </p:sp>
       <p:pic>
         <p:nvPicPr>
@@ -28914,6 +29171,10 @@
           </a:solidFill>
           <a:ln/>
         </p:spPr>
+        <p:txBody>
+          <a:bodyPr/>
+          <a:p/>
+        </p:txBody>
       </p:sp>
       <p:sp>
         <p:nvSpPr>
@@ -28978,6 +29239,10 @@
           </a:solidFill>
           <a:ln/>
         </p:spPr>
+        <p:txBody>
+          <a:bodyPr/>
+          <a:p/>
+        </p:txBody>
       </p:sp>
       <p:sp>
         <p:nvSpPr>
@@ -29103,6 +29368,10 @@
           </a:solidFill>
           <a:ln/>
         </p:spPr>
+        <p:txBody>
+          <a:bodyPr/>
+          <a:p/>
+        </p:txBody>
       </p:sp>
       <p:sp>
         <p:nvSpPr>
@@ -29228,6 +29497,10 @@
           </a:solidFill>
           <a:ln/>
         </p:spPr>
+        <p:txBody>
+          <a:bodyPr/>
+          <a:p/>
+        </p:txBody>
       </p:sp>
       <p:sp>
         <p:nvSpPr>
@@ -29355,6 +29628,10 @@
           </a:solidFill>
           <a:ln/>
         </p:spPr>
+        <p:txBody>
+          <a:bodyPr/>
+          <a:p/>
+        </p:txBody>
       </p:sp>
       <p:sp>
         <p:nvSpPr>
@@ -29480,6 +29757,10 @@
           </a:solidFill>
           <a:ln/>
         </p:spPr>
+        <p:txBody>
+          <a:bodyPr/>
+          <a:p/>
+        </p:txBody>
       </p:sp>
       <p:sp>
         <p:nvSpPr>
@@ -29544,6 +29825,10 @@
           </a:solidFill>
           <a:ln/>
         </p:spPr>
+        <p:txBody>
+          <a:bodyPr/>
+          <a:p/>
+        </p:txBody>
       </p:sp>
       <p:sp>
         <p:nvSpPr>
@@ -29669,6 +29954,10 @@
           </a:solidFill>
           <a:ln/>
         </p:spPr>
+        <p:txBody>
+          <a:bodyPr/>
+          <a:p/>
+        </p:txBody>
       </p:sp>
       <p:sp>
         <p:nvSpPr>
@@ -29794,6 +30083,10 @@
           </a:solidFill>
           <a:ln/>
         </p:spPr>
+        <p:txBody>
+          <a:bodyPr/>
+          <a:p/>
+        </p:txBody>
       </p:sp>
       <p:sp>
         <p:nvSpPr>
@@ -29919,6 +30212,10 @@
           </a:solidFill>
           <a:ln/>
         </p:spPr>
+        <p:txBody>
+          <a:bodyPr/>
+          <a:p/>
+        </p:txBody>
       </p:sp>
       <p:sp>
         <p:nvSpPr>
@@ -30044,6 +30341,10 @@
           </a:solidFill>
           <a:ln/>
         </p:spPr>
+        <p:txBody>
+          <a:bodyPr/>
+          <a:p/>
+        </p:txBody>
       </p:sp>
       <p:sp>
         <p:nvSpPr>
@@ -30178,7 +30479,7 @@
                 <a:ea typeface="Courier New" pitchFamily="34" charset="-122"/>
                 <a:cs typeface="Courier New" pitchFamily="34" charset="-120"/>
               </a:rPr>
-              <a:t>S22</a:t>
+              <a:t>S21</a:t>
             </a:r>
             <a:endParaRPr lang="en-US" sz="1800" dirty="0"/>
           </a:p>
@@ -30479,6 +30780,10 @@
           </a:solidFill>
           <a:ln/>
         </p:spPr>
+        <p:txBody>
+          <a:bodyPr/>
+          <a:p/>
+        </p:txBody>
       </p:sp>
       <p:sp>
         <p:nvSpPr>
@@ -30675,6 +30980,10 @@
           </a:solidFill>
           <a:ln/>
         </p:spPr>
+        <p:txBody>
+          <a:bodyPr/>
+          <a:p/>
+        </p:txBody>
       </p:sp>
       <p:sp>
         <p:nvSpPr>
@@ -30739,6 +31048,10 @@
           </a:solidFill>
           <a:ln/>
         </p:spPr>
+        <p:txBody>
+          <a:bodyPr/>
+          <a:p/>
+        </p:txBody>
       </p:sp>
       <p:sp>
         <p:nvSpPr>
@@ -30935,6 +31248,10 @@
           </a:solidFill>
           <a:ln/>
         </p:spPr>
+        <p:txBody>
+          <a:bodyPr/>
+          <a:p/>
+        </p:txBody>
       </p:sp>
       <p:sp>
         <p:nvSpPr>
@@ -30999,6 +31316,10 @@
           </a:solidFill>
           <a:ln/>
         </p:spPr>
+        <p:txBody>
+          <a:bodyPr/>
+          <a:p/>
+        </p:txBody>
       </p:sp>
       <p:sp>
         <p:nvSpPr>
@@ -31195,6 +31516,10 @@
           </a:solidFill>
           <a:ln/>
         </p:spPr>
+        <p:txBody>
+          <a:bodyPr/>
+          <a:p/>
+        </p:txBody>
       </p:sp>
       <p:sp>
         <p:nvSpPr>
@@ -31259,6 +31584,10 @@
           </a:solidFill>
           <a:ln/>
         </p:spPr>
+        <p:txBody>
+          <a:bodyPr/>
+          <a:p/>
+        </p:txBody>
       </p:sp>
       <p:sp>
         <p:nvSpPr>
@@ -31689,6 +32018,10 @@
           </a:solidFill>
           <a:ln/>
         </p:spPr>
+        <p:txBody>
+          <a:bodyPr/>
+          <a:p/>
+        </p:txBody>
       </p:sp>
       <p:sp>
         <p:nvSpPr>
@@ -31757,6 +32090,10 @@
             <a:prstDash val="solid"/>
           </a:ln>
         </p:spPr>
+        <p:txBody>
+          <a:bodyPr/>
+          <a:p/>
+        </p:txBody>
       </p:sp>
       <p:sp>
         <p:nvSpPr>
@@ -31827,6 +32164,10 @@
             <a:prstDash val="solid"/>
           </a:ln>
         </p:spPr>
+        <p:txBody>
+          <a:bodyPr/>
+          <a:p/>
+        </p:txBody>
       </p:sp>
       <p:sp>
         <p:nvSpPr>

</xml_diff>